<commit_message>
Regenerar la plantilla PowerPoint con las notas corregidas
Co-Authored-By: Claude Opus 5.5 <noreply@anthropic.com>
</commit_message>
<xml_diff>
--- a/plantillas/presentacion_proyecto.pptx
+++ b/plantillas/presentacion_proyecto.pptx
@@ -109,7 +109,7 @@
   <p:extLst>
     <p:ext uri="{521415D9-36F7-43E2-AB2F-B90AF26B5E84}">
       <p14:sectionLst xmlns:p14="http://schemas.microsoft.com/office/powerpoint/2010/main">
-        <p14:section name="Presentación" id="{9959c177-ba6f-7095-053e-81ef223ff02d}">
+        <p14:section name="Presentación" id="{8b8d0560-7d1a-29d2-2733-ac257c8a950e}">
           <p14:sldIdLst>
             <p14:sldId id="256"/>
             <p14:sldId id="257"/>
@@ -520,7 +520,7 @@
           <a:p>
             <a:r>
               <a:rPr lang="en-US" dirty="0"/>
-              <a:t>Diapositiva 1. El problema: la situación y por qué importa. Criterios para las tres diapositivas: una idea central por diapositiva, poco texto, títulos claros, gráficos simples y ningún resultado sin justificar. Los textos en gris son pistas: desaparecen al escribir y no se ven al proyectar. Simulación formativa: sin datos personales ni cifras inventadas.</a:t>
+              <a:t>Diapositiva 1. El problema: la situación y por qué importa. Criterios para las tres diapositivas: una idea central por diapositiva, poco texto, títulos claros, gráficos simples y ningún resultado sin justificar. Los textos de los recuadros son pistas: desaparecen al escribir y no se ven al proyectar. Simulación formativa: sin datos personales ni cifras inventadas.</a:t>
             </a:r>
             <a:endParaRPr lang="en-US" dirty="0"/>
           </a:p>
@@ -608,7 +608,7 @@
           <a:p>
             <a:r>
               <a:rPr lang="en-US" dirty="0"/>
-              <a:t>Diapositiva 2. La solución: cómo funciona, en tres pasos, y con qué herramientas. Criterios para las tres diapositivas: una idea central por diapositiva, poco texto, títulos claros, gráficos simples y ningún resultado sin justificar. Los textos en gris son pistas: desaparecen al escribir y no se ven al proyectar. Simulación formativa: sin datos personales ni cifras inventadas.</a:t>
+              <a:t>Diapositiva 2. La solución: cómo funciona, en tres pasos, y con qué herramientas. Criterios para las tres diapositivas: una idea central por diapositiva, poco texto, títulos claros, gráficos simples y ningún resultado sin justificar. Los textos de los recuadros son pistas: desaparecen al escribir y no se ven al proyectar. Simulación formativa: sin datos personales ni cifras inventadas.</a:t>
             </a:r>
             <a:endParaRPr lang="en-US" dirty="0"/>
           </a:p>
@@ -696,7 +696,7 @@
           <a:p>
             <a:r>
               <a:rPr lang="en-US" dirty="0"/>
-              <a:t>Diapositiva 3. Los beneficios: resultados esperados, los dos indicadores del documento y las principales precauciones. Criterios para las tres diapositivas: una idea central por diapositiva, poco texto, títulos claros, gráficos simples y ningún resultado sin justificar. Los textos en gris son pistas: desaparecen al escribir y no se ven al proyectar. Simulación formativa: sin datos personales ni cifras inventadas.</a:t>
+              <a:t>Diapositiva 3. Los beneficios: resultados esperados, los dos indicadores del documento y las principales precauciones. Criterios para las tres diapositivas: una idea central por diapositiva, poco texto, títulos claros, gráficos simples y ningún resultado sin justificar. Los textos de los recuadros son pistas: desaparecen al escribir y no se ven al proyectar. Simulación formativa: sin datos personales ni cifras inventadas.</a:t>
             </a:r>
             <a:endParaRPr lang="en-US" dirty="0"/>
           </a:p>

</xml_diff>